<commit_message>
Set the cover to the OOP course project and its date
The review heading now reads OOP COURSE PROJECT and the date is
22/10/2026, which is a Thursday, so the day field is unchanged.

Co-Authored-By: Claude Opus 5 <noreply@anthropic.com>
Claude-Session: https://claude.ai/code/session_01H2ZRi5GaRea7JptvNnoYxB
</commit_message>
<xml_diff>
--- a/Library_Management_System.pptx
+++ b/Library_Management_System.pptx
@@ -727,7 +727,7 @@
                 <a:ea typeface="Arial" pitchFamily="34" charset="-122"/>
                 <a:cs typeface="Arial" pitchFamily="34" charset="-120"/>
               </a:rPr>
-              <a:t>PPT FOR </a:t>
+              <a:t>OOP COURSE PROJECT</a:t>
             </a:r>
             <a:r>
               <a:rPr lang="en-US" sz="1600" b="1" dirty="0" smtClean="0">
@@ -738,7 +738,7 @@
                 <a:ea typeface="Arial" pitchFamily="34" charset="-122"/>
                 <a:cs typeface="Arial" pitchFamily="34" charset="-120"/>
               </a:rPr>
-              <a:t>MID-SEMESTER </a:t>
+              <a:t/>
             </a:r>
             <a:r>
               <a:rPr lang="en-US" sz="1600" b="1" dirty="0" smtClean="0">
@@ -749,7 +749,7 @@
                 <a:ea typeface="Arial" pitchFamily="34" charset="-122"/>
                 <a:cs typeface="Arial" pitchFamily="34" charset="-120"/>
               </a:rPr>
-              <a:t>REVIEW </a:t>
+              <a:t/>
             </a:r>
             <a:r>
               <a:rPr lang="en-US" sz="1600" b="1" dirty="0">
@@ -760,7 +760,7 @@
                 <a:ea typeface="Arial" pitchFamily="34" charset="-122"/>
                 <a:cs typeface="Arial" pitchFamily="34" charset="-120"/>
               </a:rPr>
-              <a:t>– SEPTEMBER 2026</a:t>
+              <a:t/>
             </a:r>
             <a:endParaRPr lang="en-US" sz="1600" dirty="0"/>
           </a:p>
@@ -878,7 +878,7 @@
                 <a:ea typeface="Arial" pitchFamily="34" charset="-122"/>
                 <a:cs typeface="Arial" pitchFamily="34" charset="-120"/>
               </a:rPr>
-              <a:t>Div:-  C          Group No :-  3          Day:-  Thursday          Date:-  24/09/2026</a:t>
+              <a:t>Div:-  C          Group No :-  3          Day:-  Thursday          Date:-  22/10/2026</a:t>
             </a:r>
             <a:endParaRPr lang="en-US" sz="1600" dirty="0"/>
           </a:p>

</xml_diff>